<commit_message>
Promote prior-opposed resting-limit hour-complete as family baseline.
Fix ST gate availability to live_after+1h, regenerate NQ/MNQ/YM/MYM books and family/friends investment materials, and document the causality correction in Platform.md and PROGRESS.log.

Co-authored-by: Cursor <cursoragent@cursor.com>
</commit_message>
<xml_diff>
--- a/live/state/family_friends_funding_package/PITCH_DECK.pptx
+++ b/live/state/family_friends_funding_package/PITCH_DECK.pptx
@@ -3812,7 +3812,7 @@
                           </a:solidFill>
                           <a:latin typeface="Aptos"/>
                         </a:rPr>
-                        <a:t>2010-11-29-2026-03-06</a:t>
+                        <a:t>2021-03-04-2026-03-06</a:t>
                       </a:r>
                     </a:p>
                   </a:txBody>
@@ -3835,7 +3835,7 @@
                           </a:solidFill>
                           <a:latin typeface="Aptos"/>
                         </a:rPr>
-                        <a:t>$57,990</a:t>
+                        <a:t>$128,249</a:t>
                       </a:r>
                     </a:p>
                   </a:txBody>
@@ -3858,7 +3858,7 @@
                           </a:solidFill>
                           <a:latin typeface="Aptos"/>
                         </a:rPr>
-                        <a:t>23.2%</a:t>
+                        <a:t>51.3%</a:t>
                       </a:r>
                     </a:p>
                   </a:txBody>
@@ -3881,7 +3881,7 @@
                           </a:solidFill>
                           <a:latin typeface="Aptos"/>
                         </a:rPr>
-                        <a:t>-0.06</a:t>
+                        <a:t>-0.07</a:t>
                       </a:r>
                     </a:p>
                   </a:txBody>
@@ -3998,7 +3998,7 @@
                           </a:solidFill>
                           <a:latin typeface="Aptos"/>
                         </a:rPr>
-                        <a:t>2021-03-04-2026-03-06</a:t>
+                        <a:t>2021-03-04-2026-03-03</a:t>
                       </a:r>
                     </a:p>
                   </a:txBody>
@@ -4021,7 +4021,7 @@
                           </a:solidFill>
                           <a:latin typeface="Aptos"/>
                         </a:rPr>
-                        <a:t>$10,048</a:t>
+                        <a:t>$13,323</a:t>
                       </a:r>
                     </a:p>
                   </a:txBody>
@@ -4044,7 +4044,7 @@
                           </a:solidFill>
                           <a:latin typeface="Aptos"/>
                         </a:rPr>
-                        <a:t>20.1%</a:t>
+                        <a:t>26.6%</a:t>
                       </a:r>
                     </a:p>
                   </a:txBody>
@@ -4067,7 +4067,7 @@
                           </a:solidFill>
                           <a:latin typeface="Aptos"/>
                         </a:rPr>
-                        <a:t>-0.09</a:t>
+                        <a:t>-0.06</a:t>
                       </a:r>
                     </a:p>
                   </a:txBody>
@@ -10218,7 +10218,7 @@
                           </a:solidFill>
                           <a:latin typeface="Aptos"/>
                         </a:rPr>
-                        <a:t>-0.09</a:t>
+                        <a:t>-0.06</a:t>
                       </a:r>
                     </a:p>
                   </a:txBody>
@@ -10241,7 +10241,7 @@
                           </a:solidFill>
                           <a:latin typeface="Aptos"/>
                         </a:rPr>
-                        <a:t>13.9%</a:t>
+                        <a:t>21.7%</a:t>
                       </a:r>
                     </a:p>
                   </a:txBody>
@@ -10289,7 +10289,7 @@
                           </a:solidFill>
                           <a:latin typeface="Aptos"/>
                         </a:rPr>
-                        <a:t>-0.06</a:t>
+                        <a:t>-0.07</a:t>
                       </a:r>
                     </a:p>
                   </a:txBody>
@@ -10312,7 +10312,7 @@
                           </a:solidFill>
                           <a:latin typeface="Aptos"/>
                         </a:rPr>
-                        <a:t>28.4%</a:t>
+                        <a:t>39.1%</a:t>
                       </a:r>
                     </a:p>
                   </a:txBody>

</xml_diff>